<commit_message>
feat(k6): add Ch3 custom metric threshold rules demo and slide
Add ch3_custom_metric_rules.js demo with a matching Ch3 slide (built via
scripts/add_ch3_custom_metric_rules_slide.py), and sync the codelab,
lecture scripts, transcripts and recording notes.

Co-Authored-By: Claude Opus 5.5 <noreply@anthropic.com>
</commit_message>
<xml_diff>
--- a/k6/slides/Ch3_k6_Quality_Gates.pptx
+++ b/k6/slides/Ch3_k6_Quality_Gates.pptx
@@ -15,6 +15,7 @@
     <p:sldId id="260" r:id="rId11"/>
     <p:sldId id="261" r:id="rId12"/>
     <p:sldId id="262" r:id="rId13"/>
+    <p:sldId id="268" r:id="rId26"/>
     <p:sldId id="263" r:id="rId14"/>
     <p:sldId id="264" r:id="rId15"/>
     <p:sldId id="265" r:id="rId16"/>
@@ -16721,6 +16722,1674 @@
         <p:nvSpPr>
           <p:cNvPr id="422" name="Google Shape;422;p12">
             <a:hlinkClick r:id="rId3"/>
+          </p:cNvPr>
+          <p:cNvSpPr/>
+          <p:nvPr/>
+        </p:nvSpPr>
+        <p:spPr>
+          <a:xfrm>
+            <a:off x="502920" y="8869680"/>
+            <a:ext cx="6035040" cy="219456"/>
+          </a:xfrm>
+          <a:prstGeom prst="roundRect">
+            <a:avLst>
+              <a:gd fmla="val 16667" name="adj"/>
+            </a:avLst>
+          </a:prstGeom>
+          <a:solidFill>
+            <a:srgbClr val="F8FAFC"/>
+          </a:solidFill>
+          <a:ln cap="flat" cmpd="sng" w="12700">
+            <a:solidFill>
+              <a:srgbClr val="94A3B8"/>
+            </a:solidFill>
+            <a:prstDash val="solid"/>
+            <a:round/>
+            <a:headEnd len="sm" w="sm" type="none"/>
+            <a:tailEnd len="sm" w="sm" type="none"/>
+          </a:ln>
+          <a:effectLst>
+            <a:outerShdw blurRad="40000" rotWithShape="0" dir="5400000" dist="23000">
+              <a:srgbClr val="000000">
+                <a:alpha val="34902"/>
+              </a:srgbClr>
+            </a:outerShdw>
+          </a:effectLst>
+        </p:spPr>
+        <p:txBody>
+          <a:bodyPr anchorCtr="0" anchor="ctr" bIns="0" lIns="109725" spcFirstLastPara="1" rIns="109725" wrap="square" tIns="0">
+            <a:noAutofit/>
+          </a:bodyPr>
+          <a:lstStyle/>
+          <a:p>
+            <a:pPr indent="0" lvl="0" marL="0" marR="0" rtl="0" algn="l">
+              <a:spcBef>
+                <a:spcPts val="0"/>
+              </a:spcBef>
+              <a:spcAft>
+                <a:spcPts val="0"/>
+              </a:spcAft>
+              <a:buNone/>
+            </a:pPr>
+            <a:r>
+              <a:rPr b="1" lang="en-US" sz="850">
+                <a:solidFill>
+                  <a:srgbClr val="1E293B"/>
+                </a:solidFill>
+                <a:latin typeface="Noto Sans"/>
+                <a:ea typeface="Noto Sans"/>
+                <a:cs typeface="Noto Sans"/>
+                <a:sym typeface="Noto Sans"/>
+              </a:rPr>
+              <a:t>▶ 課程實戰 Codelabs：</a:t>
+            </a:r>
+            <a:r>
+              <a:rPr b="0" lang="en-US" sz="850">
+                <a:solidFill>
+                  <a:srgbClr val="2563EB"/>
+                </a:solidFill>
+                <a:latin typeface="Noto Sans"/>
+                <a:ea typeface="Noto Sans"/>
+                <a:cs typeface="Noto Sans"/>
+                <a:sym typeface="Noto Sans"/>
+              </a:rPr>
+              <a:t>tedmax100.github.io/o11y_lab_for_dummies/k6-performance-testing/</a:t>
+            </a:r>
+            <a:endParaRPr/>
+          </a:p>
+        </p:txBody>
+      </p:sp>
+    </p:spTree>
+  </p:cSld>
+  <p:clrMapOvr>
+    <a:masterClrMapping/>
+  </p:clrMapOvr>
+</p:sld>
+</file>
+
+<file path=ppt/slides/slide13.xml><?xml version="1.0" encoding="utf-8"?>
+<p:sld xmlns:a="http://schemas.openxmlformats.org/drawingml/2006/main" xmlns:p="http://schemas.openxmlformats.org/presentationml/2006/main" xmlns:r="http://schemas.openxmlformats.org/officeDocument/2006/relationships">
+  <p:cSld>
+    <p:spTree>
+      <p:nvGrpSpPr>
+        <p:cNvPr id="1" name=""/>
+        <p:cNvGrpSpPr/>
+        <p:nvPr/>
+      </p:nvGrpSpPr>
+      <p:grpSpPr/>
+      <p:sp>
+        <p:nvSpPr>
+          <p:cNvPr id="2" name="Title 1"/>
+          <p:cNvSpPr>
+            <a:spLocks noGrp="1"/>
+          </p:cNvSpPr>
+          <p:nvPr>
+            <p:ph type="title"/>
+          </p:nvPr>
+        </p:nvSpPr>
+        <p:spPr/>
+        <p:txBody>
+          <a:bodyPr/>
+          <a:lstStyle/>
+          <a:p/>
+        </p:txBody>
+      </p:sp>
+      <p:sp>
+        <p:nvSpPr>
+          <p:cNvPr id="3" name="Rectangle 2"/>
+          <p:cNvSpPr/>
+          <p:nvPr/>
+        </p:nvSpPr>
+        <p:spPr>
+          <a:xfrm>
+            <a:off x="0" y="0"/>
+            <a:ext cx="16256000" cy="9144000"/>
+          </a:xfrm>
+          <a:prstGeom prst="rect">
+            <a:avLst/>
+          </a:prstGeom>
+          <a:solidFill>
+            <a:srgbClr val="F8FAFC"/>
+          </a:solidFill>
+          <a:ln>
+            <a:noFill/>
+          </a:ln>
+          <a:effectLst/>
+        </p:spPr>
+        <p:style>
+          <a:lnRef idx="1">
+            <a:schemeClr val="accent1"/>
+          </a:lnRef>
+          <a:fillRef idx="3">
+            <a:schemeClr val="accent1"/>
+          </a:fillRef>
+          <a:effectRef idx="2">
+            <a:schemeClr val="accent1"/>
+          </a:effectRef>
+          <a:fontRef idx="minor">
+            <a:schemeClr val="lt1"/>
+          </a:fontRef>
+        </p:style>
+        <p:txBody>
+          <a:bodyPr rtlCol="0" anchor="ctr"/>
+          <a:lstStyle/>
+          <a:p>
+            <a:pPr algn="ctr"/>
+          </a:p>
+        </p:txBody>
+      </p:sp>
+      <p:sp>
+        <p:nvSpPr>
+          <p:cNvPr id="4" name="TextBox 3"/>
+          <p:cNvSpPr txBox="1"/>
+          <p:nvPr/>
+        </p:nvSpPr>
+        <p:spPr>
+          <a:xfrm>
+            <a:off x="708837" y="333375"/>
+            <a:ext cx="14838325" cy="666750"/>
+          </a:xfrm>
+          <a:prstGeom prst="rect">
+            <a:avLst/>
+          </a:prstGeom>
+          <a:noFill/>
+        </p:spPr>
+        <p:txBody>
+          <a:bodyPr wrap="square" anchor="ctr" lIns="0" tIns="0" rIns="0" bIns="0">
+            <a:spAutoFit/>
+          </a:bodyPr>
+          <a:lstStyle/>
+          <a:p>
+            <a:pPr algn="l"/>
+            <a:r>
+              <a:rPr sz="3000" b="1">
+                <a:solidFill>
+                  <a:srgbClr val="0F172A"/>
+                </a:solidFill>
+                <a:latin typeface="Noto Sans CJK TC"/>
+                <a:ea typeface="Noto Sans CJK TC"/>
+              </a:rPr>
+              <a:t>自訂指標的 5 個規則：宣告、單位、命名、Tags、去哪裡看</a:t>
+            </a:r>
+          </a:p>
+        </p:txBody>
+      </p:sp>
+      <p:sp>
+        <p:nvSpPr>
+          <p:cNvPr id="5" name="TextBox 4"/>
+          <p:cNvSpPr txBox="1"/>
+          <p:nvPr/>
+        </p:nvSpPr>
+        <p:spPr>
+          <a:xfrm>
+            <a:off x="708837" y="1000125"/>
+            <a:ext cx="14838325" cy="357187"/>
+          </a:xfrm>
+          <a:prstGeom prst="rect">
+            <a:avLst/>
+          </a:prstGeom>
+          <a:noFill/>
+        </p:spPr>
+        <p:txBody>
+          <a:bodyPr wrap="square" anchor="ctr" lIns="0" tIns="0" rIns="0" bIns="0">
+            <a:spAutoFit/>
+          </a:bodyPr>
+          <a:lstStyle/>
+          <a:p>
+            <a:pPr algn="l"/>
+            <a:r>
+              <a:rPr sz="1500" b="0">
+                <a:solidFill>
+                  <a:srgbClr val="64748B"/>
+                </a:solidFill>
+                <a:latin typeface="Noto Sans CJK TC"/>
+                <a:ea typeface="Noto Sans CJK TC"/>
+              </a:rPr>
+              <a:t>四種型態會用了，接下來是定義與使用時最容易踩的坑（完整腳本：k6/demos/ch3_custom_metric_rules.js）</a:t>
+            </a:r>
+          </a:p>
+        </p:txBody>
+      </p:sp>
+      <p:sp>
+        <p:nvSpPr>
+          <p:cNvPr id="6" name="Rounded Rectangle 5"/>
+          <p:cNvSpPr/>
+          <p:nvPr/>
+        </p:nvSpPr>
+        <p:spPr>
+          <a:xfrm>
+            <a:off x="708837" y="1571625"/>
+            <a:ext cx="7560930" cy="6738937"/>
+          </a:xfrm>
+          <a:prstGeom prst="roundRect">
+            <a:avLst>
+              <a:gd name="adj" fmla="val 3000"/>
+            </a:avLst>
+          </a:prstGeom>
+          <a:solidFill>
+            <a:srgbClr val="0F172A"/>
+          </a:solidFill>
+          <a:ln w="12700">
+            <a:solidFill>
+              <a:srgbClr val="334155"/>
+            </a:solidFill>
+          </a:ln>
+          <a:effectLst/>
+        </p:spPr>
+        <p:style>
+          <a:lnRef idx="1">
+            <a:schemeClr val="accent1"/>
+          </a:lnRef>
+          <a:fillRef idx="3">
+            <a:schemeClr val="accent1"/>
+          </a:fillRef>
+          <a:effectRef idx="2">
+            <a:schemeClr val="accent1"/>
+          </a:effectRef>
+          <a:fontRef idx="minor">
+            <a:schemeClr val="lt1"/>
+          </a:fontRef>
+        </p:style>
+        <p:txBody>
+          <a:bodyPr rtlCol="0" anchor="ctr" wrap="square" lIns="259906" tIns="141767" rIns="165395" bIns="141767"/>
+          <a:lstStyle/>
+          <a:p>
+            <a:pPr algn="l">
+              <a:lnSpc>
+                <a:spcPct val="112000"/>
+              </a:lnSpc>
+            </a:pPr>
+            <a:r>
+              <a:rPr sz="1620" b="0">
+                <a:solidFill>
+                  <a:srgbClr val="C4B5FD"/>
+                </a:solidFill>
+                <a:latin typeface="Noto Sans Mono CJK TC"/>
+                <a:ea typeface="Noto Sans Mono CJK TC"/>
+              </a:rPr>
+              <a:t>import</a:t>
+            </a:r>
+            <a:r>
+              <a:rPr sz="1620" b="0">
+                <a:solidFill>
+                  <a:srgbClr val="E2E8F0"/>
+                </a:solidFill>
+                <a:latin typeface="Noto Sans Mono CJK TC"/>
+                <a:ea typeface="Noto Sans Mono CJK TC"/>
+              </a:rPr>
+              <a:t> { Counter, Rate, Trend } </a:t>
+            </a:r>
+            <a:r>
+              <a:rPr sz="1620" b="0">
+                <a:solidFill>
+                  <a:srgbClr val="C4B5FD"/>
+                </a:solidFill>
+                <a:latin typeface="Noto Sans Mono CJK TC"/>
+                <a:ea typeface="Noto Sans Mono CJK TC"/>
+              </a:rPr>
+              <a:t>from</a:t>
+            </a:r>
+            <a:r>
+              <a:rPr sz="1620" b="0">
+                <a:solidFill>
+                  <a:srgbClr val="4ADE80"/>
+                </a:solidFill>
+                <a:latin typeface="Noto Sans Mono CJK TC"/>
+                <a:ea typeface="Noto Sans Mono CJK TC"/>
+              </a:rPr>
+              <a:t> 'k6/metrics';</a:t>
+            </a:r>
+          </a:p>
+          <a:p>
+            <a:pPr algn="l">
+              <a:lnSpc>
+                <a:spcPct val="112000"/>
+              </a:lnSpc>
+            </a:pPr>
+            <a:r>
+              <a:rPr sz="1620" b="0">
+                <a:solidFill>
+                  <a:srgbClr val="E2E8F0"/>
+                </a:solidFill>
+                <a:latin typeface="Noto Sans Mono CJK TC"/>
+                <a:ea typeface="Noto Sans Mono CJK TC"/>
+              </a:rPr>
+              <a:t/>
+            </a:r>
+          </a:p>
+          <a:p>
+            <a:pPr algn="l">
+              <a:lnSpc>
+                <a:spcPct val="112000"/>
+              </a:lnSpc>
+            </a:pPr>
+            <a:r>
+              <a:rPr sz="1620" b="0">
+                <a:solidFill>
+                  <a:srgbClr val="94A3B8"/>
+                </a:solidFill>
+                <a:latin typeface="Noto Sans Mono CJK TC"/>
+                <a:ea typeface="Noto Sans Mono CJK TC"/>
+              </a:rPr>
+              <a:t>// ① 在最上層宣告  ③ 名稱只用英數與底線</a:t>
+            </a:r>
+          </a:p>
+          <a:p>
+            <a:pPr algn="l">
+              <a:lnSpc>
+                <a:spcPct val="112000"/>
+              </a:lnSpc>
+            </a:pPr>
+            <a:r>
+              <a:rPr sz="1620" b="0">
+                <a:solidFill>
+                  <a:srgbClr val="C4B5FD"/>
+                </a:solidFill>
+                <a:latin typeface="Noto Sans Mono CJK TC"/>
+                <a:ea typeface="Noto Sans Mono CJK TC"/>
+              </a:rPr>
+              <a:t>const</a:t>
+            </a:r>
+            <a:r>
+              <a:rPr sz="1620" b="0">
+                <a:solidFill>
+                  <a:srgbClr val="E2E8F0"/>
+                </a:solidFill>
+                <a:latin typeface="Noto Sans Mono CJK TC"/>
+                <a:ea typeface="Noto Sans Mono CJK TC"/>
+              </a:rPr>
+              <a:t> orders = </a:t>
+            </a:r>
+            <a:r>
+              <a:rPr sz="1620" b="0">
+                <a:solidFill>
+                  <a:srgbClr val="C4B5FD"/>
+                </a:solidFill>
+                <a:latin typeface="Noto Sans Mono CJK TC"/>
+                <a:ea typeface="Noto Sans Mono CJK TC"/>
+              </a:rPr>
+              <a:t>new</a:t>
+            </a:r>
+            <a:r>
+              <a:rPr sz="1620" b="0">
+                <a:solidFill>
+                  <a:srgbClr val="E2E8F0"/>
+                </a:solidFill>
+                <a:latin typeface="Noto Sans Mono CJK TC"/>
+                <a:ea typeface="Noto Sans Mono CJK TC"/>
+              </a:rPr>
+              <a:t> Counter(</a:t>
+            </a:r>
+            <a:r>
+              <a:rPr sz="1620" b="0">
+                <a:solidFill>
+                  <a:srgbClr val="4ADE80"/>
+                </a:solidFill>
+                <a:latin typeface="Noto Sans Mono CJK TC"/>
+                <a:ea typeface="Noto Sans Mono CJK TC"/>
+              </a:rPr>
+              <a:t>'orders_completed'</a:t>
+            </a:r>
+            <a:r>
+              <a:rPr sz="1620" b="0">
+                <a:solidFill>
+                  <a:srgbClr val="E2E8F0"/>
+                </a:solidFill>
+                <a:latin typeface="Noto Sans Mono CJK TC"/>
+                <a:ea typeface="Noto Sans Mono CJK TC"/>
+              </a:rPr>
+              <a:t>);</a:t>
+            </a:r>
+          </a:p>
+          <a:p>
+            <a:pPr algn="l">
+              <a:lnSpc>
+                <a:spcPct val="112000"/>
+              </a:lnSpc>
+            </a:pPr>
+            <a:r>
+              <a:rPr sz="1620" b="0">
+                <a:solidFill>
+                  <a:srgbClr val="C4B5FD"/>
+                </a:solidFill>
+                <a:latin typeface="Noto Sans Mono CJK TC"/>
+                <a:ea typeface="Noto Sans Mono CJK TC"/>
+              </a:rPr>
+              <a:t>const</a:t>
+            </a:r>
+            <a:r>
+              <a:rPr sz="1620" b="0">
+                <a:solidFill>
+                  <a:srgbClr val="E2E8F0"/>
+                </a:solidFill>
+                <a:latin typeface="Noto Sans Mono CJK TC"/>
+                <a:ea typeface="Noto Sans Mono CJK TC"/>
+              </a:rPr>
+              <a:t> success = </a:t>
+            </a:r>
+            <a:r>
+              <a:rPr sz="1620" b="0">
+                <a:solidFill>
+                  <a:srgbClr val="C4B5FD"/>
+                </a:solidFill>
+                <a:latin typeface="Noto Sans Mono CJK TC"/>
+                <a:ea typeface="Noto Sans Mono CJK TC"/>
+              </a:rPr>
+              <a:t>new</a:t>
+            </a:r>
+            <a:r>
+              <a:rPr sz="1620" b="0">
+                <a:solidFill>
+                  <a:srgbClr val="E2E8F0"/>
+                </a:solidFill>
+                <a:latin typeface="Noto Sans Mono CJK TC"/>
+                <a:ea typeface="Noto Sans Mono CJK TC"/>
+              </a:rPr>
+              <a:t> Rate(</a:t>
+            </a:r>
+            <a:r>
+              <a:rPr sz="1620" b="0">
+                <a:solidFill>
+                  <a:srgbClr val="4ADE80"/>
+                </a:solidFill>
+                <a:latin typeface="Noto Sans Mono CJK TC"/>
+                <a:ea typeface="Noto Sans Mono CJK TC"/>
+              </a:rPr>
+              <a:t>'checkout_success'</a:t>
+            </a:r>
+            <a:r>
+              <a:rPr sz="1620" b="0">
+                <a:solidFill>
+                  <a:srgbClr val="E2E8F0"/>
+                </a:solidFill>
+                <a:latin typeface="Noto Sans Mono CJK TC"/>
+                <a:ea typeface="Noto Sans Mono CJK TC"/>
+              </a:rPr>
+              <a:t>);</a:t>
+            </a:r>
+          </a:p>
+          <a:p>
+            <a:pPr algn="l">
+              <a:lnSpc>
+                <a:spcPct val="112000"/>
+              </a:lnSpc>
+            </a:pPr>
+            <a:r>
+              <a:rPr sz="1620" b="0">
+                <a:solidFill>
+                  <a:srgbClr val="94A3B8"/>
+                </a:solidFill>
+                <a:latin typeface="Noto Sans Mono CJK TC"/>
+                <a:ea typeface="Noto Sans Mono CJK TC"/>
+              </a:rPr>
+              <a:t>// ② 時間型 Trend 加 true</a:t>
+            </a:r>
+          </a:p>
+          <a:p>
+            <a:pPr algn="l">
+              <a:lnSpc>
+                <a:spcPct val="112000"/>
+              </a:lnSpc>
+            </a:pPr>
+            <a:r>
+              <a:rPr sz="1620" b="0">
+                <a:solidFill>
+                  <a:srgbClr val="C4B5FD"/>
+                </a:solidFill>
+                <a:latin typeface="Noto Sans Mono CJK TC"/>
+                <a:ea typeface="Noto Sans Mono CJK TC"/>
+              </a:rPr>
+              <a:t>const</a:t>
+            </a:r>
+            <a:r>
+              <a:rPr sz="1620" b="0">
+                <a:solidFill>
+                  <a:srgbClr val="E2E8F0"/>
+                </a:solidFill>
+                <a:latin typeface="Noto Sans Mono CJK TC"/>
+                <a:ea typeface="Noto Sans Mono CJK TC"/>
+              </a:rPr>
+              <a:t> dbTime = </a:t>
+            </a:r>
+            <a:r>
+              <a:rPr sz="1620" b="0">
+                <a:solidFill>
+                  <a:srgbClr val="C4B5FD"/>
+                </a:solidFill>
+                <a:latin typeface="Noto Sans Mono CJK TC"/>
+                <a:ea typeface="Noto Sans Mono CJK TC"/>
+              </a:rPr>
+              <a:t>new</a:t>
+            </a:r>
+            <a:r>
+              <a:rPr sz="1620" b="0">
+                <a:solidFill>
+                  <a:srgbClr val="E2E8F0"/>
+                </a:solidFill>
+                <a:latin typeface="Noto Sans Mono CJK TC"/>
+                <a:ea typeface="Noto Sans Mono CJK TC"/>
+              </a:rPr>
+              <a:t> Trend(</a:t>
+            </a:r>
+            <a:r>
+              <a:rPr sz="1620" b="0">
+                <a:solidFill>
+                  <a:srgbClr val="4ADE80"/>
+                </a:solidFill>
+                <a:latin typeface="Noto Sans Mono CJK TC"/>
+                <a:ea typeface="Noto Sans Mono CJK TC"/>
+              </a:rPr>
+              <a:t>'db_query_time'</a:t>
+            </a:r>
+            <a:r>
+              <a:rPr sz="1620" b="0">
+                <a:solidFill>
+                  <a:srgbClr val="E2E8F0"/>
+                </a:solidFill>
+                <a:latin typeface="Noto Sans Mono CJK TC"/>
+                <a:ea typeface="Noto Sans Mono CJK TC"/>
+              </a:rPr>
+              <a:t>, </a:t>
+            </a:r>
+            <a:r>
+              <a:rPr sz="1620" b="0">
+                <a:solidFill>
+                  <a:srgbClr val="C4B5FD"/>
+                </a:solidFill>
+                <a:latin typeface="Noto Sans Mono CJK TC"/>
+                <a:ea typeface="Noto Sans Mono CJK TC"/>
+              </a:rPr>
+              <a:t>true</a:t>
+            </a:r>
+            <a:r>
+              <a:rPr sz="1620" b="0">
+                <a:solidFill>
+                  <a:srgbClr val="E2E8F0"/>
+                </a:solidFill>
+                <a:latin typeface="Noto Sans Mono CJK TC"/>
+                <a:ea typeface="Noto Sans Mono CJK TC"/>
+              </a:rPr>
+              <a:t>);</a:t>
+            </a:r>
+          </a:p>
+          <a:p>
+            <a:pPr algn="l">
+              <a:lnSpc>
+                <a:spcPct val="112000"/>
+              </a:lnSpc>
+            </a:pPr>
+            <a:r>
+              <a:rPr sz="1620" b="0">
+                <a:solidFill>
+                  <a:srgbClr val="E2E8F0"/>
+                </a:solidFill>
+                <a:latin typeface="Noto Sans Mono CJK TC"/>
+                <a:ea typeface="Noto Sans Mono CJK TC"/>
+              </a:rPr>
+              <a:t/>
+            </a:r>
+          </a:p>
+          <a:p>
+            <a:pPr algn="l">
+              <a:lnSpc>
+                <a:spcPct val="112000"/>
+              </a:lnSpc>
+            </a:pPr>
+            <a:r>
+              <a:rPr sz="1620" b="0">
+                <a:solidFill>
+                  <a:srgbClr val="C4B5FD"/>
+                </a:solidFill>
+                <a:latin typeface="Noto Sans Mono CJK TC"/>
+                <a:ea typeface="Noto Sans Mono CJK TC"/>
+              </a:rPr>
+              <a:t>export const</a:t>
+            </a:r>
+            <a:r>
+              <a:rPr sz="1620" b="0">
+                <a:solidFill>
+                  <a:srgbClr val="E2E8F0"/>
+                </a:solidFill>
+                <a:latin typeface="Noto Sans Mono CJK TC"/>
+                <a:ea typeface="Noto Sans Mono CJK TC"/>
+              </a:rPr>
+              <a:t> options = { thresholds: {</a:t>
+            </a:r>
+          </a:p>
+          <a:p>
+            <a:pPr algn="l">
+              <a:lnSpc>
+                <a:spcPct val="112000"/>
+              </a:lnSpc>
+            </a:pPr>
+            <a:r>
+              <a:rPr sz="1620" b="0">
+                <a:solidFill>
+                  <a:srgbClr val="94A3B8"/>
+                </a:solidFill>
+                <a:latin typeface="Noto Sans Mono CJK TC"/>
+                <a:ea typeface="Noto Sans Mono CJK TC"/>
+              </a:rPr>
+              <a:t>  // ④ 用 tags 設門檻</a:t>
+            </a:r>
+          </a:p>
+          <a:p>
+            <a:pPr algn="l">
+              <a:lnSpc>
+                <a:spcPct val="112000"/>
+              </a:lnSpc>
+            </a:pPr>
+            <a:r>
+              <a:rPr sz="1620" b="0">
+                <a:solidFill>
+                  <a:srgbClr val="4ADE80"/>
+                </a:solidFill>
+                <a:latin typeface="Noto Sans Mono CJK TC"/>
+                <a:ea typeface="Noto Sans Mono CJK TC"/>
+              </a:rPr>
+              <a:t>  'db_query_time{endpoint:checkout}'</a:t>
+            </a:r>
+            <a:r>
+              <a:rPr sz="1620" b="0">
+                <a:solidFill>
+                  <a:srgbClr val="E2E8F0"/>
+                </a:solidFill>
+                <a:latin typeface="Noto Sans Mono CJK TC"/>
+                <a:ea typeface="Noto Sans Mono CJK TC"/>
+              </a:rPr>
+              <a:t>: [</a:t>
+            </a:r>
+            <a:r>
+              <a:rPr sz="1620" b="0">
+                <a:solidFill>
+                  <a:srgbClr val="FBBF24"/>
+                </a:solidFill>
+                <a:latin typeface="Noto Sans Mono CJK TC"/>
+                <a:ea typeface="Noto Sans Mono CJK TC"/>
+              </a:rPr>
+              <a:t>'p(95)&lt;200'</a:t>
+            </a:r>
+            <a:r>
+              <a:rPr sz="1620" b="0">
+                <a:solidFill>
+                  <a:srgbClr val="E2E8F0"/>
+                </a:solidFill>
+                <a:latin typeface="Noto Sans Mono CJK TC"/>
+                <a:ea typeface="Noto Sans Mono CJK TC"/>
+              </a:rPr>
+              <a:t>],</a:t>
+            </a:r>
+          </a:p>
+          <a:p>
+            <a:pPr algn="l">
+              <a:lnSpc>
+                <a:spcPct val="112000"/>
+              </a:lnSpc>
+            </a:pPr>
+            <a:r>
+              <a:rPr sz="1620" b="0">
+                <a:solidFill>
+                  <a:srgbClr val="E2E8F0"/>
+                </a:solidFill>
+                <a:latin typeface="Noto Sans Mono CJK TC"/>
+                <a:ea typeface="Noto Sans Mono CJK TC"/>
+              </a:rPr>
+              <a:t>} };</a:t>
+            </a:r>
+          </a:p>
+          <a:p>
+            <a:pPr algn="l">
+              <a:lnSpc>
+                <a:spcPct val="112000"/>
+              </a:lnSpc>
+            </a:pPr>
+            <a:r>
+              <a:rPr sz="1620" b="0">
+                <a:solidFill>
+                  <a:srgbClr val="E2E8F0"/>
+                </a:solidFill>
+                <a:latin typeface="Noto Sans Mono CJK TC"/>
+                <a:ea typeface="Noto Sans Mono CJK TC"/>
+              </a:rPr>
+              <a:t/>
+            </a:r>
+          </a:p>
+          <a:p>
+            <a:pPr algn="l">
+              <a:lnSpc>
+                <a:spcPct val="112000"/>
+              </a:lnSpc>
+            </a:pPr>
+            <a:r>
+              <a:rPr sz="1620" b="0">
+                <a:solidFill>
+                  <a:srgbClr val="C4B5FD"/>
+                </a:solidFill>
+                <a:latin typeface="Noto Sans Mono CJK TC"/>
+                <a:ea typeface="Noto Sans Mono CJK TC"/>
+              </a:rPr>
+              <a:t>export default function</a:t>
+            </a:r>
+            <a:r>
+              <a:rPr sz="1620" b="0">
+                <a:solidFill>
+                  <a:srgbClr val="E2E8F0"/>
+                </a:solidFill>
+                <a:latin typeface="Noto Sans Mono CJK TC"/>
+                <a:ea typeface="Noto Sans Mono CJK TC"/>
+              </a:rPr>
+              <a:t> () {</a:t>
+            </a:r>
+          </a:p>
+          <a:p>
+            <a:pPr algn="l">
+              <a:lnSpc>
+                <a:spcPct val="112000"/>
+              </a:lnSpc>
+            </a:pPr>
+            <a:r>
+              <a:rPr sz="1620" b="0">
+                <a:solidFill>
+                  <a:srgbClr val="E2E8F0"/>
+                </a:solidFill>
+                <a:latin typeface="Noto Sans Mono CJK TC"/>
+                <a:ea typeface="Noto Sans Mono CJK TC"/>
+              </a:rPr>
+              <a:t>  orders.add(1);</a:t>
+            </a:r>
+          </a:p>
+          <a:p>
+            <a:pPr algn="l">
+              <a:lnSpc>
+                <a:spcPct val="112000"/>
+              </a:lnSpc>
+            </a:pPr>
+            <a:r>
+              <a:rPr sz="1620" b="0">
+                <a:solidFill>
+                  <a:srgbClr val="E2E8F0"/>
+                </a:solidFill>
+                <a:latin typeface="Noto Sans Mono CJK TC"/>
+                <a:ea typeface="Noto Sans Mono CJK TC"/>
+              </a:rPr>
+              <a:t>  success.add(</a:t>
+            </a:r>
+            <a:r>
+              <a:rPr sz="1620" b="0">
+                <a:solidFill>
+                  <a:srgbClr val="C4B5FD"/>
+                </a:solidFill>
+                <a:latin typeface="Noto Sans Mono CJK TC"/>
+                <a:ea typeface="Noto Sans Mono CJK TC"/>
+              </a:rPr>
+              <a:t>true</a:t>
+            </a:r>
+            <a:r>
+              <a:rPr sz="1620" b="0">
+                <a:solidFill>
+                  <a:srgbClr val="E2E8F0"/>
+                </a:solidFill>
+                <a:latin typeface="Noto Sans Mono CJK TC"/>
+                <a:ea typeface="Noto Sans Mono CJK TC"/>
+              </a:rPr>
+              <a:t>);</a:t>
+            </a:r>
+          </a:p>
+          <a:p>
+            <a:pPr algn="l">
+              <a:lnSpc>
+                <a:spcPct val="112000"/>
+              </a:lnSpc>
+            </a:pPr>
+            <a:r>
+              <a:rPr sz="1620" b="0">
+                <a:solidFill>
+                  <a:srgbClr val="E2E8F0"/>
+                </a:solidFill>
+                <a:latin typeface="Noto Sans Mono CJK TC"/>
+                <a:ea typeface="Noto Sans Mono CJK TC"/>
+              </a:rPr>
+              <a:t>  dbTime.add(elapsedMs, { endpoint: </a:t>
+            </a:r>
+            <a:r>
+              <a:rPr sz="1620" b="0">
+                <a:solidFill>
+                  <a:srgbClr val="4ADE80"/>
+                </a:solidFill>
+                <a:latin typeface="Noto Sans Mono CJK TC"/>
+                <a:ea typeface="Noto Sans Mono CJK TC"/>
+              </a:rPr>
+              <a:t>'checkout'</a:t>
+            </a:r>
+            <a:r>
+              <a:rPr sz="1620" b="0">
+                <a:solidFill>
+                  <a:srgbClr val="E2E8F0"/>
+                </a:solidFill>
+                <a:latin typeface="Noto Sans Mono CJK TC"/>
+                <a:ea typeface="Noto Sans Mono CJK TC"/>
+              </a:rPr>
+              <a:t> });</a:t>
+            </a:r>
+          </a:p>
+          <a:p>
+            <a:pPr algn="l">
+              <a:lnSpc>
+                <a:spcPct val="112000"/>
+              </a:lnSpc>
+            </a:pPr>
+            <a:r>
+              <a:rPr sz="1620" b="0">
+                <a:solidFill>
+                  <a:srgbClr val="E2E8F0"/>
+                </a:solidFill>
+                <a:latin typeface="Noto Sans Mono CJK TC"/>
+                <a:ea typeface="Noto Sans Mono CJK TC"/>
+              </a:rPr>
+              <a:t>}</a:t>
+            </a:r>
+          </a:p>
+        </p:txBody>
+      </p:sp>
+      <p:sp>
+        <p:nvSpPr>
+          <p:cNvPr id="7" name="Rounded Rectangle 6"/>
+          <p:cNvSpPr/>
+          <p:nvPr/>
+        </p:nvSpPr>
+        <p:spPr>
+          <a:xfrm>
+            <a:off x="8529674" y="1571625"/>
+            <a:ext cx="7017488" cy="1238250"/>
+          </a:xfrm>
+          <a:prstGeom prst="roundRect">
+            <a:avLst>
+              <a:gd name="adj" fmla="val 8000"/>
+            </a:avLst>
+          </a:prstGeom>
+          <a:solidFill>
+            <a:srgbClr val="FFFFFF"/>
+          </a:solidFill>
+          <a:ln w="12700">
+            <a:solidFill>
+              <a:srgbClr val="E2E8F0"/>
+            </a:solidFill>
+          </a:ln>
+          <a:effectLst/>
+        </p:spPr>
+        <p:style>
+          <a:lnRef idx="1">
+            <a:schemeClr val="accent1"/>
+          </a:lnRef>
+          <a:fillRef idx="3">
+            <a:schemeClr val="accent1"/>
+          </a:fillRef>
+          <a:effectRef idx="2">
+            <a:schemeClr val="accent1"/>
+          </a:effectRef>
+          <a:fontRef idx="minor">
+            <a:schemeClr val="lt1"/>
+          </a:fontRef>
+        </p:style>
+        <p:txBody>
+          <a:bodyPr rtlCol="0" anchor="ctr"/>
+          <a:lstStyle/>
+          <a:p>
+            <a:pPr algn="ctr"/>
+          </a:p>
+        </p:txBody>
+      </p:sp>
+      <p:sp>
+        <p:nvSpPr>
+          <p:cNvPr id="8" name="Oval 7"/>
+          <p:cNvSpPr/>
+          <p:nvPr/>
+        </p:nvSpPr>
+        <p:spPr>
+          <a:xfrm>
+            <a:off x="8742325" y="1905000"/>
+            <a:ext cx="567069" cy="571500"/>
+          </a:xfrm>
+          <a:prstGeom prst="ellipse">
+            <a:avLst/>
+          </a:prstGeom>
+          <a:solidFill>
+            <a:srgbClr val="4F46E5"/>
+          </a:solidFill>
+          <a:ln>
+            <a:noFill/>
+          </a:ln>
+          <a:effectLst/>
+        </p:spPr>
+        <p:style>
+          <a:lnRef idx="1">
+            <a:schemeClr val="accent1"/>
+          </a:lnRef>
+          <a:fillRef idx="3">
+            <a:schemeClr val="accent1"/>
+          </a:fillRef>
+          <a:effectRef idx="2">
+            <a:schemeClr val="accent1"/>
+          </a:effectRef>
+          <a:fontRef idx="minor">
+            <a:schemeClr val="lt1"/>
+          </a:fontRef>
+        </p:style>
+        <p:txBody>
+          <a:bodyPr rtlCol="0" anchor="ctr" wrap="square" lIns="0" tIns="0" rIns="0" bIns="0"/>
+          <a:lstStyle/>
+          <a:p>
+            <a:pPr algn="ctr"/>
+            <a:r>
+              <a:rPr sz="1800" b="1">
+                <a:solidFill>
+                  <a:srgbClr val="FFFFFF"/>
+                </a:solidFill>
+                <a:latin typeface="Noto Sans CJK TC"/>
+                <a:ea typeface="Noto Sans CJK TC"/>
+              </a:rPr>
+              <a:t>①</a:t>
+            </a:r>
+          </a:p>
+        </p:txBody>
+      </p:sp>
+      <p:sp>
+        <p:nvSpPr>
+          <p:cNvPr id="9" name="TextBox 8"/>
+          <p:cNvSpPr txBox="1"/>
+          <p:nvPr/>
+        </p:nvSpPr>
+        <p:spPr>
+          <a:xfrm>
+            <a:off x="9474790" y="1643062"/>
+            <a:ext cx="5906976" cy="1095375"/>
+          </a:xfrm>
+          <a:prstGeom prst="rect">
+            <a:avLst/>
+          </a:prstGeom>
+          <a:noFill/>
+        </p:spPr>
+        <p:txBody>
+          <a:bodyPr wrap="square" anchor="ctr" lIns="0" tIns="0" rIns="0" bIns="0">
+            <a:spAutoFit/>
+          </a:bodyPr>
+          <a:lstStyle/>
+          <a:p>
+            <a:pPr algn="l">
+              <a:spcAft>
+                <a:spcPts val="200"/>
+              </a:spcAft>
+            </a:pPr>
+            <a:r>
+              <a:rPr sz="1739" b="1">
+                <a:solidFill>
+                  <a:srgbClr val="0F172A"/>
+                </a:solidFill>
+                <a:latin typeface="Noto Sans CJK TC"/>
+                <a:ea typeface="Noto Sans CJK TC"/>
+              </a:rPr>
+              <a:t>在最上層宣告</a:t>
+            </a:r>
+          </a:p>
+          <a:p>
+            <a:pPr algn="l">
+              <a:spcAft>
+                <a:spcPts val="200"/>
+              </a:spcAft>
+            </a:pPr>
+            <a:r>
+              <a:rPr sz="1440" b="0">
+                <a:solidFill>
+                  <a:srgbClr val="334155"/>
+                </a:solidFill>
+                <a:latin typeface="Noto Sans CJK TC"/>
+                <a:ea typeface="Noto Sans CJK TC"/>
+              </a:rPr>
+              <a:t>寫在 default function 裡，k6 直接報錯：metrics must be declared in the init context</a:t>
+            </a:r>
+          </a:p>
+        </p:txBody>
+      </p:sp>
+      <p:sp>
+        <p:nvSpPr>
+          <p:cNvPr id="10" name="Rounded Rectangle 9"/>
+          <p:cNvSpPr/>
+          <p:nvPr/>
+        </p:nvSpPr>
+        <p:spPr>
+          <a:xfrm>
+            <a:off x="8529674" y="2940843"/>
+            <a:ext cx="7017488" cy="1238250"/>
+          </a:xfrm>
+          <a:prstGeom prst="roundRect">
+            <a:avLst>
+              <a:gd name="adj" fmla="val 8000"/>
+            </a:avLst>
+          </a:prstGeom>
+          <a:solidFill>
+            <a:srgbClr val="FFFFFF"/>
+          </a:solidFill>
+          <a:ln w="12700">
+            <a:solidFill>
+              <a:srgbClr val="E2E8F0"/>
+            </a:solidFill>
+          </a:ln>
+          <a:effectLst/>
+        </p:spPr>
+        <p:style>
+          <a:lnRef idx="1">
+            <a:schemeClr val="accent1"/>
+          </a:lnRef>
+          <a:fillRef idx="3">
+            <a:schemeClr val="accent1"/>
+          </a:fillRef>
+          <a:effectRef idx="2">
+            <a:schemeClr val="accent1"/>
+          </a:effectRef>
+          <a:fontRef idx="minor">
+            <a:schemeClr val="lt1"/>
+          </a:fontRef>
+        </p:style>
+        <p:txBody>
+          <a:bodyPr rtlCol="0" anchor="ctr"/>
+          <a:lstStyle/>
+          <a:p>
+            <a:pPr algn="ctr"/>
+          </a:p>
+        </p:txBody>
+      </p:sp>
+      <p:sp>
+        <p:nvSpPr>
+          <p:cNvPr id="11" name="Oval 10"/>
+          <p:cNvSpPr/>
+          <p:nvPr/>
+        </p:nvSpPr>
+        <p:spPr>
+          <a:xfrm>
+            <a:off x="8742325" y="3274218"/>
+            <a:ext cx="567069" cy="571500"/>
+          </a:xfrm>
+          <a:prstGeom prst="ellipse">
+            <a:avLst/>
+          </a:prstGeom>
+          <a:solidFill>
+            <a:srgbClr val="4F46E5"/>
+          </a:solidFill>
+          <a:ln>
+            <a:noFill/>
+          </a:ln>
+          <a:effectLst/>
+        </p:spPr>
+        <p:style>
+          <a:lnRef idx="1">
+            <a:schemeClr val="accent1"/>
+          </a:lnRef>
+          <a:fillRef idx="3">
+            <a:schemeClr val="accent1"/>
+          </a:fillRef>
+          <a:effectRef idx="2">
+            <a:schemeClr val="accent1"/>
+          </a:effectRef>
+          <a:fontRef idx="minor">
+            <a:schemeClr val="lt1"/>
+          </a:fontRef>
+        </p:style>
+        <p:txBody>
+          <a:bodyPr rtlCol="0" anchor="ctr" wrap="square" lIns="0" tIns="0" rIns="0" bIns="0"/>
+          <a:lstStyle/>
+          <a:p>
+            <a:pPr algn="ctr"/>
+            <a:r>
+              <a:rPr sz="1800" b="1">
+                <a:solidFill>
+                  <a:srgbClr val="FFFFFF"/>
+                </a:solidFill>
+                <a:latin typeface="Noto Sans CJK TC"/>
+                <a:ea typeface="Noto Sans CJK TC"/>
+              </a:rPr>
+              <a:t>②</a:t>
+            </a:r>
+          </a:p>
+        </p:txBody>
+      </p:sp>
+      <p:sp>
+        <p:nvSpPr>
+          <p:cNvPr id="12" name="TextBox 11"/>
+          <p:cNvSpPr txBox="1"/>
+          <p:nvPr/>
+        </p:nvSpPr>
+        <p:spPr>
+          <a:xfrm>
+            <a:off x="9474790" y="3012281"/>
+            <a:ext cx="5906976" cy="1095375"/>
+          </a:xfrm>
+          <a:prstGeom prst="rect">
+            <a:avLst/>
+          </a:prstGeom>
+          <a:noFill/>
+        </p:spPr>
+        <p:txBody>
+          <a:bodyPr wrap="square" anchor="ctr" lIns="0" tIns="0" rIns="0" bIns="0">
+            <a:spAutoFit/>
+          </a:bodyPr>
+          <a:lstStyle/>
+          <a:p>
+            <a:pPr algn="l">
+              <a:spcAft>
+                <a:spcPts val="200"/>
+              </a:spcAft>
+            </a:pPr>
+            <a:r>
+              <a:rPr sz="1739" b="1">
+                <a:solidFill>
+                  <a:srgbClr val="0F172A"/>
+                </a:solidFill>
+                <a:latin typeface="Noto Sans CJK TC"/>
+                <a:ea typeface="Noto Sans CJK TC"/>
+              </a:rPr>
+              <a:t>時間型 Trend 加 true</a:t>
+            </a:r>
+          </a:p>
+          <a:p>
+            <a:pPr algn="l">
+              <a:spcAft>
+                <a:spcPts val="200"/>
+              </a:spcAft>
+            </a:pPr>
+            <a:r>
+              <a:rPr sz="1440" b="0">
+                <a:solidFill>
+                  <a:srgbClr val="334155"/>
+                </a:solidFill>
+                <a:latin typeface="Noto Sans CJK TC"/>
+                <a:ea typeface="Noto Sans CJK TC"/>
+              </a:rPr>
+              <a:t>沒加的話摘要只顯示 123.4，看不出單位；加了才會顯示 123.4ms</a:t>
+            </a:r>
+          </a:p>
+        </p:txBody>
+      </p:sp>
+      <p:sp>
+        <p:nvSpPr>
+          <p:cNvPr id="13" name="Rounded Rectangle 12"/>
+          <p:cNvSpPr/>
+          <p:nvPr/>
+        </p:nvSpPr>
+        <p:spPr>
+          <a:xfrm>
+            <a:off x="8529674" y="4310062"/>
+            <a:ext cx="7017488" cy="1238250"/>
+          </a:xfrm>
+          <a:prstGeom prst="roundRect">
+            <a:avLst>
+              <a:gd name="adj" fmla="val 8000"/>
+            </a:avLst>
+          </a:prstGeom>
+          <a:solidFill>
+            <a:srgbClr val="FFFFFF"/>
+          </a:solidFill>
+          <a:ln w="12700">
+            <a:solidFill>
+              <a:srgbClr val="E2E8F0"/>
+            </a:solidFill>
+          </a:ln>
+          <a:effectLst/>
+        </p:spPr>
+        <p:style>
+          <a:lnRef idx="1">
+            <a:schemeClr val="accent1"/>
+          </a:lnRef>
+          <a:fillRef idx="3">
+            <a:schemeClr val="accent1"/>
+          </a:fillRef>
+          <a:effectRef idx="2">
+            <a:schemeClr val="accent1"/>
+          </a:effectRef>
+          <a:fontRef idx="minor">
+            <a:schemeClr val="lt1"/>
+          </a:fontRef>
+        </p:style>
+        <p:txBody>
+          <a:bodyPr rtlCol="0" anchor="ctr"/>
+          <a:lstStyle/>
+          <a:p>
+            <a:pPr algn="ctr"/>
+          </a:p>
+        </p:txBody>
+      </p:sp>
+      <p:sp>
+        <p:nvSpPr>
+          <p:cNvPr id="14" name="Oval 13"/>
+          <p:cNvSpPr/>
+          <p:nvPr/>
+        </p:nvSpPr>
+        <p:spPr>
+          <a:xfrm>
+            <a:off x="8742325" y="4643437"/>
+            <a:ext cx="567069" cy="571500"/>
+          </a:xfrm>
+          <a:prstGeom prst="ellipse">
+            <a:avLst/>
+          </a:prstGeom>
+          <a:solidFill>
+            <a:srgbClr val="4F46E5"/>
+          </a:solidFill>
+          <a:ln>
+            <a:noFill/>
+          </a:ln>
+          <a:effectLst/>
+        </p:spPr>
+        <p:style>
+          <a:lnRef idx="1">
+            <a:schemeClr val="accent1"/>
+          </a:lnRef>
+          <a:fillRef idx="3">
+            <a:schemeClr val="accent1"/>
+          </a:fillRef>
+          <a:effectRef idx="2">
+            <a:schemeClr val="accent1"/>
+          </a:effectRef>
+          <a:fontRef idx="minor">
+            <a:schemeClr val="lt1"/>
+          </a:fontRef>
+        </p:style>
+        <p:txBody>
+          <a:bodyPr rtlCol="0" anchor="ctr" wrap="square" lIns="0" tIns="0" rIns="0" bIns="0"/>
+          <a:lstStyle/>
+          <a:p>
+            <a:pPr algn="ctr"/>
+            <a:r>
+              <a:rPr sz="1800" b="1">
+                <a:solidFill>
+                  <a:srgbClr val="FFFFFF"/>
+                </a:solidFill>
+                <a:latin typeface="Noto Sans CJK TC"/>
+                <a:ea typeface="Noto Sans CJK TC"/>
+              </a:rPr>
+              <a:t>③</a:t>
+            </a:r>
+          </a:p>
+        </p:txBody>
+      </p:sp>
+      <p:sp>
+        <p:nvSpPr>
+          <p:cNvPr id="15" name="TextBox 14"/>
+          <p:cNvSpPr txBox="1"/>
+          <p:nvPr/>
+        </p:nvSpPr>
+        <p:spPr>
+          <a:xfrm>
+            <a:off x="9474790" y="4381500"/>
+            <a:ext cx="5906976" cy="1095375"/>
+          </a:xfrm>
+          <a:prstGeom prst="rect">
+            <a:avLst/>
+          </a:prstGeom>
+          <a:noFill/>
+        </p:spPr>
+        <p:txBody>
+          <a:bodyPr wrap="square" anchor="ctr" lIns="0" tIns="0" rIns="0" bIns="0">
+            <a:spAutoFit/>
+          </a:bodyPr>
+          <a:lstStyle/>
+          <a:p>
+            <a:pPr algn="l">
+              <a:spcAft>
+                <a:spcPts val="200"/>
+              </a:spcAft>
+            </a:pPr>
+            <a:r>
+              <a:rPr sz="1739" b="1">
+                <a:solidFill>
+                  <a:srgbClr val="0F172A"/>
+                </a:solidFill>
+                <a:latin typeface="Noto Sans CJK TC"/>
+                <a:ea typeface="Noto Sans CJK TC"/>
+              </a:rPr>
+              <a:t>名稱只用英數與底線</a:t>
+            </a:r>
+          </a:p>
+          <a:p>
+            <a:pPr algn="l">
+              <a:spcAft>
+                <a:spcPts val="200"/>
+              </a:spcAft>
+            </a:pPr>
+            <a:r>
+              <a:rPr sz="1440" b="0">
+                <a:solidFill>
+                  <a:srgbClr val="334155"/>
+                </a:solidFill>
+                <a:latin typeface="Noto Sans CJK TC"/>
+                <a:ea typeface="Noto Sans CJK TC"/>
+              </a:rPr>
+              <a:t>以字母或底線開頭；用中文命名會報錯：Invalid metric name</a:t>
+            </a:r>
+          </a:p>
+        </p:txBody>
+      </p:sp>
+      <p:sp>
+        <p:nvSpPr>
+          <p:cNvPr id="16" name="Rounded Rectangle 15"/>
+          <p:cNvSpPr/>
+          <p:nvPr/>
+        </p:nvSpPr>
+        <p:spPr>
+          <a:xfrm>
+            <a:off x="8529674" y="5679281"/>
+            <a:ext cx="7017488" cy="1238250"/>
+          </a:xfrm>
+          <a:prstGeom prst="roundRect">
+            <a:avLst>
+              <a:gd name="adj" fmla="val 8000"/>
+            </a:avLst>
+          </a:prstGeom>
+          <a:solidFill>
+            <a:srgbClr val="FFFFFF"/>
+          </a:solidFill>
+          <a:ln w="12700">
+            <a:solidFill>
+              <a:srgbClr val="E2E8F0"/>
+            </a:solidFill>
+          </a:ln>
+          <a:effectLst/>
+        </p:spPr>
+        <p:style>
+          <a:lnRef idx="1">
+            <a:schemeClr val="accent1"/>
+          </a:lnRef>
+          <a:fillRef idx="3">
+            <a:schemeClr val="accent1"/>
+          </a:fillRef>
+          <a:effectRef idx="2">
+            <a:schemeClr val="accent1"/>
+          </a:effectRef>
+          <a:fontRef idx="minor">
+            <a:schemeClr val="lt1"/>
+          </a:fontRef>
+        </p:style>
+        <p:txBody>
+          <a:bodyPr rtlCol="0" anchor="ctr"/>
+          <a:lstStyle/>
+          <a:p>
+            <a:pPr algn="ctr"/>
+          </a:p>
+        </p:txBody>
+      </p:sp>
+      <p:sp>
+        <p:nvSpPr>
+          <p:cNvPr id="17" name="Oval 16"/>
+          <p:cNvSpPr/>
+          <p:nvPr/>
+        </p:nvSpPr>
+        <p:spPr>
+          <a:xfrm>
+            <a:off x="8742325" y="6012656"/>
+            <a:ext cx="567069" cy="571500"/>
+          </a:xfrm>
+          <a:prstGeom prst="ellipse">
+            <a:avLst/>
+          </a:prstGeom>
+          <a:solidFill>
+            <a:srgbClr val="4F46E5"/>
+          </a:solidFill>
+          <a:ln>
+            <a:noFill/>
+          </a:ln>
+          <a:effectLst/>
+        </p:spPr>
+        <p:style>
+          <a:lnRef idx="1">
+            <a:schemeClr val="accent1"/>
+          </a:lnRef>
+          <a:fillRef idx="3">
+            <a:schemeClr val="accent1"/>
+          </a:fillRef>
+          <a:effectRef idx="2">
+            <a:schemeClr val="accent1"/>
+          </a:effectRef>
+          <a:fontRef idx="minor">
+            <a:schemeClr val="lt1"/>
+          </a:fontRef>
+        </p:style>
+        <p:txBody>
+          <a:bodyPr rtlCol="0" anchor="ctr" wrap="square" lIns="0" tIns="0" rIns="0" bIns="0"/>
+          <a:lstStyle/>
+          <a:p>
+            <a:pPr algn="ctr"/>
+            <a:r>
+              <a:rPr sz="1800" b="1">
+                <a:solidFill>
+                  <a:srgbClr val="FFFFFF"/>
+                </a:solidFill>
+                <a:latin typeface="Noto Sans CJK TC"/>
+                <a:ea typeface="Noto Sans CJK TC"/>
+              </a:rPr>
+              <a:t>④</a:t>
+            </a:r>
+          </a:p>
+        </p:txBody>
+      </p:sp>
+      <p:sp>
+        <p:nvSpPr>
+          <p:cNvPr id="18" name="TextBox 17"/>
+          <p:cNvSpPr txBox="1"/>
+          <p:nvPr/>
+        </p:nvSpPr>
+        <p:spPr>
+          <a:xfrm>
+            <a:off x="9474790" y="5750718"/>
+            <a:ext cx="5906976" cy="1095375"/>
+          </a:xfrm>
+          <a:prstGeom prst="rect">
+            <a:avLst/>
+          </a:prstGeom>
+          <a:noFill/>
+        </p:spPr>
+        <p:txBody>
+          <a:bodyPr wrap="square" anchor="ctr" lIns="0" tIns="0" rIns="0" bIns="0">
+            <a:spAutoFit/>
+          </a:bodyPr>
+          <a:lstStyle/>
+          <a:p>
+            <a:pPr algn="l">
+              <a:spcAft>
+                <a:spcPts val="200"/>
+              </a:spcAft>
+            </a:pPr>
+            <a:r>
+              <a:rPr sz="1739" b="1">
+                <a:solidFill>
+                  <a:srgbClr val="0F172A"/>
+                </a:solidFill>
+                <a:latin typeface="Noto Sans CJK TC"/>
+                <a:ea typeface="Noto Sans CJK TC"/>
+              </a:rPr>
+              <a:t>用 tags 細分並設門檻</a:t>
+            </a:r>
+          </a:p>
+          <a:p>
+            <a:pPr algn="l">
+              <a:spcAft>
+                <a:spcPts val="200"/>
+              </a:spcAft>
+            </a:pPr>
+            <a:r>
+              <a:rPr sz="1440" b="0">
+                <a:solidFill>
+                  <a:srgbClr val="334155"/>
+                </a:solidFill>
+                <a:latin typeface="Noto Sans CJK TC"/>
+                <a:ea typeface="Noto Sans CJK TC"/>
+              </a:rPr>
+              <a:t>.add(值, { endpoint: 'checkout' }) 搭配 {endpoint:checkout} 門檻；tag 值別放動態資料</a:t>
+            </a:r>
+          </a:p>
+        </p:txBody>
+      </p:sp>
+      <p:sp>
+        <p:nvSpPr>
+          <p:cNvPr id="19" name="Rounded Rectangle 18"/>
+          <p:cNvSpPr/>
+          <p:nvPr/>
+        </p:nvSpPr>
+        <p:spPr>
+          <a:xfrm>
+            <a:off x="8529674" y="7048500"/>
+            <a:ext cx="7017488" cy="1238250"/>
+          </a:xfrm>
+          <a:prstGeom prst="roundRect">
+            <a:avLst>
+              <a:gd name="adj" fmla="val 8000"/>
+            </a:avLst>
+          </a:prstGeom>
+          <a:solidFill>
+            <a:srgbClr val="FFFFFF"/>
+          </a:solidFill>
+          <a:ln w="12700">
+            <a:solidFill>
+              <a:srgbClr val="E2E8F0"/>
+            </a:solidFill>
+          </a:ln>
+          <a:effectLst/>
+        </p:spPr>
+        <p:style>
+          <a:lnRef idx="1">
+            <a:schemeClr val="accent1"/>
+          </a:lnRef>
+          <a:fillRef idx="3">
+            <a:schemeClr val="accent1"/>
+          </a:fillRef>
+          <a:effectRef idx="2">
+            <a:schemeClr val="accent1"/>
+          </a:effectRef>
+          <a:fontRef idx="minor">
+            <a:schemeClr val="lt1"/>
+          </a:fontRef>
+        </p:style>
+        <p:txBody>
+          <a:bodyPr rtlCol="0" anchor="ctr"/>
+          <a:lstStyle/>
+          <a:p>
+            <a:pPr algn="ctr"/>
+          </a:p>
+        </p:txBody>
+      </p:sp>
+      <p:sp>
+        <p:nvSpPr>
+          <p:cNvPr id="20" name="Oval 19"/>
+          <p:cNvSpPr/>
+          <p:nvPr/>
+        </p:nvSpPr>
+        <p:spPr>
+          <a:xfrm>
+            <a:off x="8742325" y="7381875"/>
+            <a:ext cx="567069" cy="571500"/>
+          </a:xfrm>
+          <a:prstGeom prst="ellipse">
+            <a:avLst/>
+          </a:prstGeom>
+          <a:solidFill>
+            <a:srgbClr val="4F46E5"/>
+          </a:solidFill>
+          <a:ln>
+            <a:noFill/>
+          </a:ln>
+          <a:effectLst/>
+        </p:spPr>
+        <p:style>
+          <a:lnRef idx="1">
+            <a:schemeClr val="accent1"/>
+          </a:lnRef>
+          <a:fillRef idx="3">
+            <a:schemeClr val="accent1"/>
+          </a:fillRef>
+          <a:effectRef idx="2">
+            <a:schemeClr val="accent1"/>
+          </a:effectRef>
+          <a:fontRef idx="minor">
+            <a:schemeClr val="lt1"/>
+          </a:fontRef>
+        </p:style>
+        <p:txBody>
+          <a:bodyPr rtlCol="0" anchor="ctr" wrap="square" lIns="0" tIns="0" rIns="0" bIns="0"/>
+          <a:lstStyle/>
+          <a:p>
+            <a:pPr algn="ctr"/>
+            <a:r>
+              <a:rPr sz="1800" b="1">
+                <a:solidFill>
+                  <a:srgbClr val="FFFFFF"/>
+                </a:solidFill>
+                <a:latin typeface="Noto Sans CJK TC"/>
+                <a:ea typeface="Noto Sans CJK TC"/>
+              </a:rPr>
+              <a:t>⑤</a:t>
+            </a:r>
+          </a:p>
+        </p:txBody>
+      </p:sp>
+      <p:sp>
+        <p:nvSpPr>
+          <p:cNvPr id="21" name="TextBox 20"/>
+          <p:cNvSpPr txBox="1"/>
+          <p:nvPr/>
+        </p:nvSpPr>
+        <p:spPr>
+          <a:xfrm>
+            <a:off x="9474790" y="7119937"/>
+            <a:ext cx="5906976" cy="1095375"/>
+          </a:xfrm>
+          <a:prstGeom prst="rect">
+            <a:avLst/>
+          </a:prstGeom>
+          <a:noFill/>
+        </p:spPr>
+        <p:txBody>
+          <a:bodyPr wrap="square" anchor="ctr" lIns="0" tIns="0" rIns="0" bIns="0">
+            <a:spAutoFit/>
+          </a:bodyPr>
+          <a:lstStyle/>
+          <a:p>
+            <a:pPr algn="l">
+              <a:spcAft>
+                <a:spcPts val="200"/>
+              </a:spcAft>
+            </a:pPr>
+            <a:r>
+              <a:rPr sz="1739" b="1">
+                <a:solidFill>
+                  <a:srgbClr val="0F172A"/>
+                </a:solidFill>
+                <a:latin typeface="Noto Sans CJK TC"/>
+                <a:ea typeface="Noto Sans CJK TC"/>
+              </a:rPr>
+              <a:t>知道去哪裡看</a:t>
+            </a:r>
+          </a:p>
+          <a:p>
+            <a:pPr algn="l">
+              <a:spcAft>
+                <a:spcPts val="200"/>
+              </a:spcAft>
+            </a:pPr>
+            <a:r>
+              <a:rPr sz="1440" b="0">
+                <a:solidFill>
+                  <a:srgbClr val="334155"/>
+                </a:solidFill>
+                <a:latin typeface="Noto Sans CJK TC"/>
+                <a:ea typeface="Noto Sans CJK TC"/>
+              </a:rPr>
+              <a:t>終端機：摘要的 CUSTOM 區塊。Prometheus：加 k6_ 前綴，Rate 加 _rate、Counter 加 _total</a:t>
+            </a:r>
+          </a:p>
+        </p:txBody>
+      </p:sp>
+      <p:sp>
+        <p:nvSpPr>
+          <p:cNvPr id="327" name="Google Shape;327;p7">
+            <a:hlinkClick r:id="rId2"/>
           </p:cNvPr>
           <p:cNvSpPr/>
           <p:nvPr/>

</xml_diff>